<commit_message>
updated presentation and documents
</commit_message>
<xml_diff>
--- a/presentation/FCFS Presentation.pptx
+++ b/presentation/FCFS Presentation.pptx
@@ -5,7 +5,7 @@
     <p:sldMasterId id="2147483826" r:id="rId1"/>
   </p:sldMasterIdLst>
   <p:notesMasterIdLst>
-    <p:notesMasterId r:id="rId13"/>
+    <p:notesMasterId r:id="rId15"/>
   </p:notesMasterIdLst>
   <p:sldIdLst>
     <p:sldId id="256" r:id="rId2"/>
@@ -13,12 +13,14 @@
     <p:sldId id="269" r:id="rId4"/>
     <p:sldId id="257" r:id="rId5"/>
     <p:sldId id="270" r:id="rId6"/>
-    <p:sldId id="268" r:id="rId7"/>
-    <p:sldId id="260" r:id="rId8"/>
-    <p:sldId id="261" r:id="rId9"/>
-    <p:sldId id="263" r:id="rId10"/>
-    <p:sldId id="266" r:id="rId11"/>
-    <p:sldId id="267" r:id="rId12"/>
+    <p:sldId id="271" r:id="rId7"/>
+    <p:sldId id="268" r:id="rId8"/>
+    <p:sldId id="260" r:id="rId9"/>
+    <p:sldId id="261" r:id="rId10"/>
+    <p:sldId id="263" r:id="rId11"/>
+    <p:sldId id="266" r:id="rId12"/>
+    <p:sldId id="267" r:id="rId13"/>
+    <p:sldId id="272" r:id="rId14"/>
   </p:sldIdLst>
   <p:sldSz cx="12192000" cy="6858000"/>
   <p:notesSz cx="6858000" cy="9144000"/>
@@ -207,7 +209,7 @@
           <a:p>
             <a:fld id="{A3F00E0A-26B8-438F-8C49-C4126C0B2F07}" type="datetimeFigureOut">
               <a:rPr lang="en-CA" smtClean="0"/>
-              <a:t>2026-08-28</a:t>
+              <a:t>2026-09-05</a:t>
             </a:fld>
             <a:endParaRPr lang="en-CA"/>
           </a:p>
@@ -792,7 +794,7 @@
           <a:p>
             <a:fld id="{6C0CC533-38F2-4480-88E0-3DE04AB45AF2}" type="slidenum">
               <a:rPr lang="en-CA" smtClean="0"/>
-              <a:t>6</a:t>
+              <a:t>7</a:t>
             </a:fld>
             <a:endParaRPr lang="en-CA"/>
           </a:p>
@@ -855,6 +857,93 @@
           <a:bodyPr/>
           <a:lstStyle/>
           <a:p>
+            <a:r>
+              <a:rPr lang="en-CA" dirty="0"/>
+              <a:t>Class 1 is the delay sensitive class, difference in served rate between class 1 and class 2 – on y axis</a:t>
+            </a:r>
+          </a:p>
+        </p:txBody>
+      </p:sp>
+      <p:sp>
+        <p:nvSpPr>
+          <p:cNvPr id="4" name="Slide Number Placeholder 3"/>
+          <p:cNvSpPr>
+            <a:spLocks noGrp="1"/>
+          </p:cNvSpPr>
+          <p:nvPr>
+            <p:ph type="sldNum" sz="quarter" idx="5"/>
+          </p:nvPr>
+        </p:nvSpPr>
+        <p:spPr/>
+        <p:txBody>
+          <a:bodyPr/>
+          <a:lstStyle/>
+          <a:p>
+            <a:fld id="{6C0CC533-38F2-4480-88E0-3DE04AB45AF2}" type="slidenum">
+              <a:rPr lang="en-CA" smtClean="0"/>
+              <a:t>9</a:t>
+            </a:fld>
+            <a:endParaRPr lang="en-CA"/>
+          </a:p>
+        </p:txBody>
+      </p:sp>
+    </p:spTree>
+    <p:extLst>
+      <p:ext uri="{BB962C8B-B14F-4D97-AF65-F5344CB8AC3E}">
+        <p14:creationId xmlns:p14="http://schemas.microsoft.com/office/powerpoint/2010/main" val="904085001"/>
+      </p:ext>
+    </p:extLst>
+  </p:cSld>
+  <p:clrMapOvr>
+    <a:masterClrMapping/>
+  </p:clrMapOvr>
+</p:notes>
+</file>
+
+<file path=ppt/notesSlides/notesSlide6.xml><?xml version="1.0" encoding="utf-8"?>
+<p:notes xmlns:a="http://schemas.openxmlformats.org/drawingml/2006/main" xmlns:r="http://schemas.openxmlformats.org/officeDocument/2006/relationships" xmlns:p="http://schemas.openxmlformats.org/presentationml/2006/main">
+  <p:cSld>
+    <p:spTree>
+      <p:nvGrpSpPr>
+        <p:cNvPr id="1" name=""/>
+        <p:cNvGrpSpPr/>
+        <p:nvPr/>
+      </p:nvGrpSpPr>
+      <p:grpSpPr>
+        <a:xfrm>
+          <a:off x="0" y="0"/>
+          <a:ext cx="0" cy="0"/>
+          <a:chOff x="0" y="0"/>
+          <a:chExt cx="0" cy="0"/>
+        </a:xfrm>
+      </p:grpSpPr>
+      <p:sp>
+        <p:nvSpPr>
+          <p:cNvPr id="2" name="Slide Image Placeholder 1"/>
+          <p:cNvSpPr>
+            <a:spLocks noGrp="1" noRot="1" noChangeAspect="1"/>
+          </p:cNvSpPr>
+          <p:nvPr>
+            <p:ph type="sldImg"/>
+          </p:nvPr>
+        </p:nvSpPr>
+        <p:spPr/>
+      </p:sp>
+      <p:sp>
+        <p:nvSpPr>
+          <p:cNvPr id="3" name="Notes Placeholder 2"/>
+          <p:cNvSpPr>
+            <a:spLocks noGrp="1"/>
+          </p:cNvSpPr>
+          <p:nvPr>
+            <p:ph type="body" idx="1"/>
+          </p:nvPr>
+        </p:nvSpPr>
+        <p:spPr/>
+        <p:txBody>
+          <a:bodyPr/>
+          <a:lstStyle/>
+          <a:p>
             <a:endParaRPr lang="en-CA" dirty="0"/>
           </a:p>
         </p:txBody>
@@ -877,6 +966,90 @@
             <a:fld id="{6C0CC533-38F2-4480-88E0-3DE04AB45AF2}" type="slidenum">
               <a:rPr lang="en-CA" smtClean="0"/>
               <a:t>10</a:t>
+            </a:fld>
+            <a:endParaRPr lang="en-CA"/>
+          </a:p>
+        </p:txBody>
+      </p:sp>
+    </p:spTree>
+    <p:extLst>
+      <p:ext uri="{BB962C8B-B14F-4D97-AF65-F5344CB8AC3E}">
+        <p14:creationId xmlns:p14="http://schemas.microsoft.com/office/powerpoint/2010/main" val="4286335202"/>
+      </p:ext>
+    </p:extLst>
+  </p:cSld>
+  <p:clrMapOvr>
+    <a:masterClrMapping/>
+  </p:clrMapOvr>
+</p:notes>
+</file>
+
+<file path=ppt/notesSlides/notesSlide7.xml><?xml version="1.0" encoding="utf-8"?>
+<p:notes xmlns:a="http://schemas.openxmlformats.org/drawingml/2006/main" xmlns:r="http://schemas.openxmlformats.org/officeDocument/2006/relationships" xmlns:p="http://schemas.openxmlformats.org/presentationml/2006/main">
+  <p:cSld>
+    <p:spTree>
+      <p:nvGrpSpPr>
+        <p:cNvPr id="1" name=""/>
+        <p:cNvGrpSpPr/>
+        <p:nvPr/>
+      </p:nvGrpSpPr>
+      <p:grpSpPr>
+        <a:xfrm>
+          <a:off x="0" y="0"/>
+          <a:ext cx="0" cy="0"/>
+          <a:chOff x="0" y="0"/>
+          <a:chExt cx="0" cy="0"/>
+        </a:xfrm>
+      </p:grpSpPr>
+      <p:sp>
+        <p:nvSpPr>
+          <p:cNvPr id="2" name="Slide Image Placeholder 1"/>
+          <p:cNvSpPr>
+            <a:spLocks noGrp="1" noRot="1" noChangeAspect="1"/>
+          </p:cNvSpPr>
+          <p:nvPr>
+            <p:ph type="sldImg"/>
+          </p:nvPr>
+        </p:nvSpPr>
+        <p:spPr/>
+      </p:sp>
+      <p:sp>
+        <p:nvSpPr>
+          <p:cNvPr id="3" name="Notes Placeholder 2"/>
+          <p:cNvSpPr>
+            <a:spLocks noGrp="1"/>
+          </p:cNvSpPr>
+          <p:nvPr>
+            <p:ph type="body" idx="1"/>
+          </p:nvPr>
+        </p:nvSpPr>
+        <p:spPr/>
+        <p:txBody>
+          <a:bodyPr/>
+          <a:lstStyle/>
+          <a:p>
+            <a:endParaRPr lang="en-CA" dirty="0"/>
+          </a:p>
+        </p:txBody>
+      </p:sp>
+      <p:sp>
+        <p:nvSpPr>
+          <p:cNvPr id="4" name="Slide Number Placeholder 3"/>
+          <p:cNvSpPr>
+            <a:spLocks noGrp="1"/>
+          </p:cNvSpPr>
+          <p:nvPr>
+            <p:ph type="sldNum" sz="quarter" idx="5"/>
+          </p:nvPr>
+        </p:nvSpPr>
+        <p:spPr/>
+        <p:txBody>
+          <a:bodyPr/>
+          <a:lstStyle/>
+          <a:p>
+            <a:fld id="{6C0CC533-38F2-4480-88E0-3DE04AB45AF2}" type="slidenum">
+              <a:rPr lang="en-CA" smtClean="0"/>
+              <a:t>11</a:t>
             </a:fld>
             <a:endParaRPr lang="en-CA"/>
           </a:p>
@@ -1026,7 +1199,7 @@
           <a:p>
             <a:fld id="{7559F276-CA16-4B7F-AC4C-2EDD18BC89A1}" type="datetimeFigureOut">
               <a:rPr lang="en-CA" smtClean="0"/>
-              <a:t>2026-08-28</a:t>
+              <a:t>2026-09-05</a:t>
             </a:fld>
             <a:endParaRPr lang="en-CA"/>
           </a:p>
@@ -1196,7 +1369,7 @@
           <a:p>
             <a:fld id="{7559F276-CA16-4B7F-AC4C-2EDD18BC89A1}" type="datetimeFigureOut">
               <a:rPr lang="en-CA" smtClean="0"/>
-              <a:t>2026-08-28</a:t>
+              <a:t>2026-09-05</a:t>
             </a:fld>
             <a:endParaRPr lang="en-CA"/>
           </a:p>
@@ -1376,7 +1549,7 @@
           <a:p>
             <a:fld id="{7559F276-CA16-4B7F-AC4C-2EDD18BC89A1}" type="datetimeFigureOut">
               <a:rPr lang="en-CA" smtClean="0"/>
-              <a:t>2026-08-28</a:t>
+              <a:t>2026-09-05</a:t>
             </a:fld>
             <a:endParaRPr lang="en-CA"/>
           </a:p>
@@ -1546,7 +1719,7 @@
           <a:p>
             <a:fld id="{7559F276-CA16-4B7F-AC4C-2EDD18BC89A1}" type="datetimeFigureOut">
               <a:rPr lang="en-CA" smtClean="0"/>
-              <a:t>2026-08-28</a:t>
+              <a:t>2026-09-05</a:t>
             </a:fld>
             <a:endParaRPr lang="en-CA"/>
           </a:p>
@@ -1792,7 +1965,7 @@
           <a:p>
             <a:fld id="{7559F276-CA16-4B7F-AC4C-2EDD18BC89A1}" type="datetimeFigureOut">
               <a:rPr lang="en-CA" smtClean="0"/>
-              <a:t>2026-08-28</a:t>
+              <a:t>2026-09-05</a:t>
             </a:fld>
             <a:endParaRPr lang="en-CA"/>
           </a:p>
@@ -2024,7 +2197,7 @@
           <a:p>
             <a:fld id="{7559F276-CA16-4B7F-AC4C-2EDD18BC89A1}" type="datetimeFigureOut">
               <a:rPr lang="en-CA" smtClean="0"/>
-              <a:t>2026-08-28</a:t>
+              <a:t>2026-09-05</a:t>
             </a:fld>
             <a:endParaRPr lang="en-CA"/>
           </a:p>
@@ -2391,7 +2564,7 @@
           <a:p>
             <a:fld id="{7559F276-CA16-4B7F-AC4C-2EDD18BC89A1}" type="datetimeFigureOut">
               <a:rPr lang="en-CA" smtClean="0"/>
-              <a:t>2026-08-28</a:t>
+              <a:t>2026-09-05</a:t>
             </a:fld>
             <a:endParaRPr lang="en-CA"/>
           </a:p>
@@ -2509,7 +2682,7 @@
           <a:p>
             <a:fld id="{7559F276-CA16-4B7F-AC4C-2EDD18BC89A1}" type="datetimeFigureOut">
               <a:rPr lang="en-CA" smtClean="0"/>
-              <a:t>2026-08-28</a:t>
+              <a:t>2026-09-05</a:t>
             </a:fld>
             <a:endParaRPr lang="en-CA"/>
           </a:p>
@@ -2604,7 +2777,7 @@
           <a:p>
             <a:fld id="{7559F276-CA16-4B7F-AC4C-2EDD18BC89A1}" type="datetimeFigureOut">
               <a:rPr lang="en-CA" smtClean="0"/>
-              <a:t>2026-08-28</a:t>
+              <a:t>2026-09-05</a:t>
             </a:fld>
             <a:endParaRPr lang="en-CA"/>
           </a:p>
@@ -2881,7 +3054,7 @@
           <a:p>
             <a:fld id="{7559F276-CA16-4B7F-AC4C-2EDD18BC89A1}" type="datetimeFigureOut">
               <a:rPr lang="en-CA" smtClean="0"/>
-              <a:t>2026-08-28</a:t>
+              <a:t>2026-09-05</a:t>
             </a:fld>
             <a:endParaRPr lang="en-CA"/>
           </a:p>
@@ -3138,7 +3311,7 @@
           <a:p>
             <a:fld id="{7559F276-CA16-4B7F-AC4C-2EDD18BC89A1}" type="datetimeFigureOut">
               <a:rPr lang="en-CA" smtClean="0"/>
-              <a:t>2026-08-28</a:t>
+              <a:t>2026-09-05</a:t>
             </a:fld>
             <a:endParaRPr lang="en-CA"/>
           </a:p>
@@ -3351,7 +3524,7 @@
           <a:p>
             <a:fld id="{7559F276-CA16-4B7F-AC4C-2EDD18BC89A1}" type="datetimeFigureOut">
               <a:rPr lang="en-CA" smtClean="0"/>
-              <a:t>2026-08-28</a:t>
+              <a:t>2026-09-05</a:t>
             </a:fld>
             <a:endParaRPr lang="en-CA"/>
           </a:p>
@@ -3892,6 +4065,334 @@
           <p:cNvPr id="2" name="Title 1">
             <a:extLst>
               <a:ext uri="{FF2B5EF4-FFF2-40B4-BE49-F238E27FC236}">
+                <a16:creationId xmlns:a16="http://schemas.microsoft.com/office/drawing/2014/main" id="{7C41D3A9-0297-4B7C-9883-BD87C6C835BB}"/>
+              </a:ext>
+            </a:extLst>
+          </p:cNvPr>
+          <p:cNvSpPr>
+            <a:spLocks noGrp="1"/>
+          </p:cNvSpPr>
+          <p:nvPr>
+            <p:ph type="title"/>
+          </p:nvPr>
+        </p:nvSpPr>
+        <p:spPr>
+          <a:xfrm>
+            <a:off x="838200" y="212346"/>
+            <a:ext cx="10515600" cy="1325563"/>
+          </a:xfrm>
+        </p:spPr>
+        <p:txBody>
+          <a:bodyPr>
+            <a:normAutofit/>
+          </a:bodyPr>
+          <a:lstStyle/>
+          <a:p>
+            <a:r>
+              <a:rPr lang="en-CA" sz="4000" dirty="0"/>
+              <a:t>Cancellation redistributes access and does not waste capacity</a:t>
+            </a:r>
+          </a:p>
+        </p:txBody>
+      </p:sp>
+      <p:pic>
+        <p:nvPicPr>
+          <p:cNvPr id="4" name="Content Placeholder 8">
+            <a:extLst>
+              <a:ext uri="{FF2B5EF4-FFF2-40B4-BE49-F238E27FC236}">
+                <a16:creationId xmlns:a16="http://schemas.microsoft.com/office/drawing/2014/main" id="{A6C18586-3ECC-41E4-925E-079E425422DA}"/>
+              </a:ext>
+            </a:extLst>
+          </p:cNvPr>
+          <p:cNvPicPr>
+            <a:picLocks noGrp="1" noChangeAspect="1"/>
+          </p:cNvPicPr>
+          <p:nvPr>
+            <p:ph idx="1"/>
+          </p:nvPr>
+        </p:nvPicPr>
+        <p:blipFill rotWithShape="1">
+          <a:blip r:embed="rId3"/>
+          <a:srcRect l="894"/>
+          <a:stretch/>
+        </p:blipFill>
+        <p:spPr>
+          <a:xfrm>
+            <a:off x="439400" y="1600200"/>
+            <a:ext cx="5562009" cy="3532504"/>
+          </a:xfrm>
+        </p:spPr>
+      </p:pic>
+      <p:sp>
+        <p:nvSpPr>
+          <p:cNvPr id="5" name="Content Placeholder 11">
+            <a:extLst>
+              <a:ext uri="{FF2B5EF4-FFF2-40B4-BE49-F238E27FC236}">
+                <a16:creationId xmlns:a16="http://schemas.microsoft.com/office/drawing/2014/main" id="{8300D28E-ABE5-4FED-B30F-C34DC7CD9D3A}"/>
+              </a:ext>
+            </a:extLst>
+          </p:cNvPr>
+          <p:cNvSpPr txBox="1">
+            <a:spLocks/>
+          </p:cNvSpPr>
+          <p:nvPr/>
+        </p:nvSpPr>
+        <p:spPr>
+          <a:xfrm>
+            <a:off x="782871" y="5311292"/>
+            <a:ext cx="10810033" cy="1325562"/>
+          </a:xfrm>
+          <a:prstGeom prst="rect">
+            <a:avLst/>
+          </a:prstGeom>
+        </p:spPr>
+        <p:txBody>
+          <a:bodyPr vert="horz" lIns="91440" tIns="45720" rIns="91440" bIns="45720" rtlCol="0">
+            <a:normAutofit fontScale="92500" lnSpcReduction="10000"/>
+          </a:bodyPr>
+          <a:lstStyle>
+            <a:lvl1pPr marL="228600" indent="-228600" algn="l" defTabSz="914400" rtl="0" eaLnBrk="1" latinLnBrk="0" hangingPunct="1">
+              <a:lnSpc>
+                <a:spcPct val="90000"/>
+              </a:lnSpc>
+              <a:spcBef>
+                <a:spcPts val="1000"/>
+              </a:spcBef>
+              <a:buFont typeface="Arial" panose="020B0604020202020204" pitchFamily="34" charset="0"/>
+              <a:buChar char="•"/>
+              <a:defRPr sz="2800" kern="1200">
+                <a:solidFill>
+                  <a:schemeClr val="tx1"/>
+                </a:solidFill>
+                <a:latin typeface="+mn-lt"/>
+                <a:ea typeface="+mn-ea"/>
+                <a:cs typeface="+mn-cs"/>
+              </a:defRPr>
+            </a:lvl1pPr>
+            <a:lvl2pPr marL="685800" indent="-228600" algn="l" defTabSz="914400" rtl="0" eaLnBrk="1" latinLnBrk="0" hangingPunct="1">
+              <a:lnSpc>
+                <a:spcPct val="90000"/>
+              </a:lnSpc>
+              <a:spcBef>
+                <a:spcPts val="500"/>
+              </a:spcBef>
+              <a:buFont typeface="Arial" panose="020B0604020202020204" pitchFamily="34" charset="0"/>
+              <a:buChar char="•"/>
+              <a:defRPr sz="2400" kern="1200">
+                <a:solidFill>
+                  <a:schemeClr val="tx1"/>
+                </a:solidFill>
+                <a:latin typeface="+mn-lt"/>
+                <a:ea typeface="+mn-ea"/>
+                <a:cs typeface="+mn-cs"/>
+              </a:defRPr>
+            </a:lvl2pPr>
+            <a:lvl3pPr marL="1143000" indent="-228600" algn="l" defTabSz="914400" rtl="0" eaLnBrk="1" latinLnBrk="0" hangingPunct="1">
+              <a:lnSpc>
+                <a:spcPct val="90000"/>
+              </a:lnSpc>
+              <a:spcBef>
+                <a:spcPts val="500"/>
+              </a:spcBef>
+              <a:buFont typeface="Arial" panose="020B0604020202020204" pitchFamily="34" charset="0"/>
+              <a:buChar char="•"/>
+              <a:defRPr sz="2000" kern="1200">
+                <a:solidFill>
+                  <a:schemeClr val="tx1"/>
+                </a:solidFill>
+                <a:latin typeface="+mn-lt"/>
+                <a:ea typeface="+mn-ea"/>
+                <a:cs typeface="+mn-cs"/>
+              </a:defRPr>
+            </a:lvl3pPr>
+            <a:lvl4pPr marL="1600200" indent="-228600" algn="l" defTabSz="914400" rtl="0" eaLnBrk="1" latinLnBrk="0" hangingPunct="1">
+              <a:lnSpc>
+                <a:spcPct val="90000"/>
+              </a:lnSpc>
+              <a:spcBef>
+                <a:spcPts val="500"/>
+              </a:spcBef>
+              <a:buFont typeface="Arial" panose="020B0604020202020204" pitchFamily="34" charset="0"/>
+              <a:buChar char="•"/>
+              <a:defRPr sz="1800" kern="1200">
+                <a:solidFill>
+                  <a:schemeClr val="tx1"/>
+                </a:solidFill>
+                <a:latin typeface="+mn-lt"/>
+                <a:ea typeface="+mn-ea"/>
+                <a:cs typeface="+mn-cs"/>
+              </a:defRPr>
+            </a:lvl4pPr>
+            <a:lvl5pPr marL="2057400" indent="-228600" algn="l" defTabSz="914400" rtl="0" eaLnBrk="1" latinLnBrk="0" hangingPunct="1">
+              <a:lnSpc>
+                <a:spcPct val="90000"/>
+              </a:lnSpc>
+              <a:spcBef>
+                <a:spcPts val="500"/>
+              </a:spcBef>
+              <a:buFont typeface="Arial" panose="020B0604020202020204" pitchFamily="34" charset="0"/>
+              <a:buChar char="•"/>
+              <a:defRPr sz="1800" kern="1200">
+                <a:solidFill>
+                  <a:schemeClr val="tx1"/>
+                </a:solidFill>
+                <a:latin typeface="+mn-lt"/>
+                <a:ea typeface="+mn-ea"/>
+                <a:cs typeface="+mn-cs"/>
+              </a:defRPr>
+            </a:lvl5pPr>
+            <a:lvl6pPr marL="2514600" indent="-228600" algn="l" defTabSz="914400" rtl="0" eaLnBrk="1" latinLnBrk="0" hangingPunct="1">
+              <a:lnSpc>
+                <a:spcPct val="90000"/>
+              </a:lnSpc>
+              <a:spcBef>
+                <a:spcPts val="500"/>
+              </a:spcBef>
+              <a:buFont typeface="Arial" panose="020B0604020202020204" pitchFamily="34" charset="0"/>
+              <a:buChar char="•"/>
+              <a:defRPr sz="1800" kern="1200">
+                <a:solidFill>
+                  <a:schemeClr val="tx1"/>
+                </a:solidFill>
+                <a:latin typeface="+mn-lt"/>
+                <a:ea typeface="+mn-ea"/>
+                <a:cs typeface="+mn-cs"/>
+              </a:defRPr>
+            </a:lvl6pPr>
+            <a:lvl7pPr marL="2971800" indent="-228600" algn="l" defTabSz="914400" rtl="0" eaLnBrk="1" latinLnBrk="0" hangingPunct="1">
+              <a:lnSpc>
+                <a:spcPct val="90000"/>
+              </a:lnSpc>
+              <a:spcBef>
+                <a:spcPts val="500"/>
+              </a:spcBef>
+              <a:buFont typeface="Arial" panose="020B0604020202020204" pitchFamily="34" charset="0"/>
+              <a:buChar char="•"/>
+              <a:defRPr sz="1800" kern="1200">
+                <a:solidFill>
+                  <a:schemeClr val="tx1"/>
+                </a:solidFill>
+                <a:latin typeface="+mn-lt"/>
+                <a:ea typeface="+mn-ea"/>
+                <a:cs typeface="+mn-cs"/>
+              </a:defRPr>
+            </a:lvl7pPr>
+            <a:lvl8pPr marL="3429000" indent="-228600" algn="l" defTabSz="914400" rtl="0" eaLnBrk="1" latinLnBrk="0" hangingPunct="1">
+              <a:lnSpc>
+                <a:spcPct val="90000"/>
+              </a:lnSpc>
+              <a:spcBef>
+                <a:spcPts val="500"/>
+              </a:spcBef>
+              <a:buFont typeface="Arial" panose="020B0604020202020204" pitchFamily="34" charset="0"/>
+              <a:buChar char="•"/>
+              <a:defRPr sz="1800" kern="1200">
+                <a:solidFill>
+                  <a:schemeClr val="tx1"/>
+                </a:solidFill>
+                <a:latin typeface="+mn-lt"/>
+                <a:ea typeface="+mn-ea"/>
+                <a:cs typeface="+mn-cs"/>
+              </a:defRPr>
+            </a:lvl8pPr>
+            <a:lvl9pPr marL="3886200" indent="-228600" algn="l" defTabSz="914400" rtl="0" eaLnBrk="1" latinLnBrk="0" hangingPunct="1">
+              <a:lnSpc>
+                <a:spcPct val="90000"/>
+              </a:lnSpc>
+              <a:spcBef>
+                <a:spcPts val="500"/>
+              </a:spcBef>
+              <a:buFont typeface="Arial" panose="020B0604020202020204" pitchFamily="34" charset="0"/>
+              <a:buChar char="•"/>
+              <a:defRPr sz="1800" kern="1200">
+                <a:solidFill>
+                  <a:schemeClr val="tx1"/>
+                </a:solidFill>
+                <a:latin typeface="+mn-lt"/>
+                <a:ea typeface="+mn-ea"/>
+                <a:cs typeface="+mn-cs"/>
+              </a:defRPr>
+            </a:lvl9pPr>
+          </a:lstStyle>
+          <a:p>
+            <a:r>
+              <a:rPr lang="en-CA" sz="2400" dirty="0"/>
+              <a:t>Under high demand, cancellations transfer access from one class to the other without significant pooled changes.</a:t>
+            </a:r>
+          </a:p>
+          <a:p>
+            <a:r>
+              <a:rPr lang="en-CA" sz="2400" dirty="0"/>
+              <a:t>Higher cancellation rate can improve utilization and waiting time by allowing appointments to be booked before behavior thresholds.</a:t>
+            </a:r>
+          </a:p>
+        </p:txBody>
+      </p:sp>
+      <p:pic>
+        <p:nvPicPr>
+          <p:cNvPr id="6" name="Content Placeholder 4">
+            <a:extLst>
+              <a:ext uri="{FF2B5EF4-FFF2-40B4-BE49-F238E27FC236}">
+                <a16:creationId xmlns:a16="http://schemas.microsoft.com/office/drawing/2014/main" id="{40932703-1B5B-4BE8-BB30-66B2474230B0}"/>
+              </a:ext>
+            </a:extLst>
+          </p:cNvPr>
+          <p:cNvPicPr>
+            <a:picLocks noChangeAspect="1"/>
+          </p:cNvPicPr>
+          <p:nvPr/>
+        </p:nvPicPr>
+        <p:blipFill>
+          <a:blip r:embed="rId4"/>
+          <a:stretch>
+            <a:fillRect/>
+          </a:stretch>
+        </p:blipFill>
+        <p:spPr>
+          <a:xfrm>
+            <a:off x="6133180" y="1600200"/>
+            <a:ext cx="5567408" cy="3532504"/>
+          </a:xfrm>
+          <a:prstGeom prst="rect">
+            <a:avLst/>
+          </a:prstGeom>
+        </p:spPr>
+      </p:pic>
+    </p:spTree>
+    <p:extLst>
+      <p:ext uri="{BB962C8B-B14F-4D97-AF65-F5344CB8AC3E}">
+        <p14:creationId xmlns:p14="http://schemas.microsoft.com/office/powerpoint/2010/main" val="810838374"/>
+      </p:ext>
+    </p:extLst>
+  </p:cSld>
+  <p:clrMapOvr>
+    <a:masterClrMapping/>
+  </p:clrMapOvr>
+</p:sld>
+</file>
+
+<file path=ppt/slides/slide11.xml><?xml version="1.0" encoding="utf-8"?>
+<p:sld xmlns:a="http://schemas.openxmlformats.org/drawingml/2006/main" xmlns:r="http://schemas.openxmlformats.org/officeDocument/2006/relationships" xmlns:p="http://schemas.openxmlformats.org/presentationml/2006/main">
+  <p:cSld>
+    <p:spTree>
+      <p:nvGrpSpPr>
+        <p:cNvPr id="1" name=""/>
+        <p:cNvGrpSpPr/>
+        <p:nvPr/>
+      </p:nvGrpSpPr>
+      <p:grpSpPr>
+        <a:xfrm>
+          <a:off x="0" y="0"/>
+          <a:ext cx="0" cy="0"/>
+          <a:chOff x="0" y="0"/>
+          <a:chExt cx="0" cy="0"/>
+        </a:xfrm>
+      </p:grpSpPr>
+      <p:sp>
+        <p:nvSpPr>
+          <p:cNvPr id="2" name="Title 1">
+            <a:extLst>
+              <a:ext uri="{FF2B5EF4-FFF2-40B4-BE49-F238E27FC236}">
                 <a16:creationId xmlns:a16="http://schemas.microsoft.com/office/drawing/2014/main" id="{46B1F8A5-D20D-418C-8C5D-1FD3CD639F36}"/>
               </a:ext>
             </a:extLst>
@@ -3956,7 +4457,7 @@
             </a:pPr>
             <a:r>
               <a:rPr lang="en-CA" dirty="0"/>
-              <a:t>Balking mainly redistributes access away from the delay-sensitive group.</a:t>
+              <a:t>Balking magnitude mainly redistributes access away from the delay-sensitive group.</a:t>
             </a:r>
           </a:p>
           <a:p>
@@ -3989,7 +4490,7 @@
             </a:pPr>
             <a:r>
               <a:rPr lang="en-CA" dirty="0"/>
-              <a:t>Delay sensitivity matters along with behaviour probability.</a:t>
+              <a:t>Delay sensitivity matters along with behaviour magnitude.</a:t>
             </a:r>
           </a:p>
           <a:p>
@@ -4001,7 +4502,15 @@
             </a:pPr>
             <a:r>
               <a:rPr lang="en-CA" dirty="0"/>
-              <a:t>Balking is a stronger driver of class access than no-show**</a:t>
+              <a:t>No-show magnitude is the stronger driver of class access </a:t>
+            </a:r>
+            <a:r>
+              <a:rPr lang="en-US" altLang="zh-CN" dirty="0"/>
+              <a:t>while</a:t>
+            </a:r>
+            <a:r>
+              <a:rPr lang="en-CA" dirty="0"/>
+              <a:t> balking becomes more important as demand increases</a:t>
             </a:r>
           </a:p>
           <a:p>
@@ -4080,7 +4589,7 @@
 </p:sld>
 </file>
 
-<file path=ppt/slides/slide11.xml><?xml version="1.0" encoding="utf-8"?>
+<file path=ppt/slides/slide12.xml><?xml version="1.0" encoding="utf-8"?>
 <p:sld xmlns:a="http://schemas.openxmlformats.org/drawingml/2006/main" xmlns:r="http://schemas.openxmlformats.org/officeDocument/2006/relationships" xmlns:p="http://schemas.openxmlformats.org/presentationml/2006/main">
   <p:cSld>
     <p:spTree>
@@ -4180,15 +4689,7 @@
             </a:pPr>
             <a:r>
               <a:rPr lang="en-CA" dirty="0"/>
-              <a:t>What are the win-win situations of class access </a:t>
-            </a:r>
-            <a:r>
-              <a:rPr lang="en-CA"/>
-              <a:t>and efficiency </a:t>
-            </a:r>
-            <a:r>
-              <a:rPr lang="en-CA" dirty="0"/>
-              <a:t>when policies become flexible?</a:t>
+              <a:t>What are the win-win situations of class access and efficiency when policies become flexible?</a:t>
             </a:r>
           </a:p>
         </p:txBody>
@@ -4240,6 +4741,174 @@
     <p:extLst>
       <p:ext uri="{BB962C8B-B14F-4D97-AF65-F5344CB8AC3E}">
         <p14:creationId xmlns:p14="http://schemas.microsoft.com/office/powerpoint/2010/main" val="4293721139"/>
+      </p:ext>
+    </p:extLst>
+  </p:cSld>
+  <p:clrMapOvr>
+    <a:masterClrMapping/>
+  </p:clrMapOvr>
+</p:sld>
+</file>
+
+<file path=ppt/slides/slide13.xml><?xml version="1.0" encoding="utf-8"?>
+<p:sld xmlns:a="http://schemas.openxmlformats.org/drawingml/2006/main" xmlns:r="http://schemas.openxmlformats.org/officeDocument/2006/relationships" xmlns:p="http://schemas.openxmlformats.org/presentationml/2006/main">
+  <p:cSld>
+    <p:spTree>
+      <p:nvGrpSpPr>
+        <p:cNvPr id="1" name=""/>
+        <p:cNvGrpSpPr/>
+        <p:nvPr/>
+      </p:nvGrpSpPr>
+      <p:grpSpPr>
+        <a:xfrm>
+          <a:off x="0" y="0"/>
+          <a:ext cx="0" cy="0"/>
+          <a:chOff x="0" y="0"/>
+          <a:chExt cx="0" cy="0"/>
+        </a:xfrm>
+      </p:grpSpPr>
+      <p:sp>
+        <p:nvSpPr>
+          <p:cNvPr id="2" name="Title 1">
+            <a:extLst>
+              <a:ext uri="{FF2B5EF4-FFF2-40B4-BE49-F238E27FC236}">
+                <a16:creationId xmlns:a16="http://schemas.microsoft.com/office/drawing/2014/main" id="{CA13CD48-42A2-4E86-9C49-FED4D6F61340}"/>
+              </a:ext>
+            </a:extLst>
+          </p:cNvPr>
+          <p:cNvSpPr>
+            <a:spLocks noGrp="1"/>
+          </p:cNvSpPr>
+          <p:nvPr>
+            <p:ph type="title"/>
+          </p:nvPr>
+        </p:nvSpPr>
+        <p:spPr/>
+        <p:txBody>
+          <a:bodyPr/>
+          <a:lstStyle/>
+          <a:p>
+            <a:r>
+              <a:rPr lang="en-CA" dirty="0"/>
+              <a:t>Policies in consideration</a:t>
+            </a:r>
+          </a:p>
+        </p:txBody>
+      </p:sp>
+      <p:sp>
+        <p:nvSpPr>
+          <p:cNvPr id="3" name="Content Placeholder 2">
+            <a:extLst>
+              <a:ext uri="{FF2B5EF4-FFF2-40B4-BE49-F238E27FC236}">
+                <a16:creationId xmlns:a16="http://schemas.microsoft.com/office/drawing/2014/main" id="{99621A18-CA15-4AC4-90FE-BCA5BCB74E4D}"/>
+              </a:ext>
+            </a:extLst>
+          </p:cNvPr>
+          <p:cNvSpPr>
+            <a:spLocks noGrp="1"/>
+          </p:cNvSpPr>
+          <p:nvPr>
+            <p:ph idx="1"/>
+          </p:nvPr>
+        </p:nvSpPr>
+        <p:spPr/>
+        <p:txBody>
+          <a:bodyPr/>
+          <a:lstStyle/>
+          <a:p>
+            <a:pPr marL="514350" indent="-514350">
+              <a:buAutoNum type="arabicPeriod"/>
+            </a:pPr>
+            <a:r>
+              <a:rPr lang="en-CA" dirty="0"/>
+              <a:t>Reservation</a:t>
+            </a:r>
+          </a:p>
+          <a:p>
+            <a:pPr lvl="1"/>
+            <a:r>
+              <a:rPr lang="en-CA" dirty="0"/>
+              <a:t>Allowing one class to have priority for certain appointments.</a:t>
+            </a:r>
+          </a:p>
+          <a:p>
+            <a:pPr lvl="1"/>
+            <a:r>
+              <a:rPr lang="en-CA" dirty="0"/>
+              <a:t>This policy chooses both reserved slots per day and reservation horizon.</a:t>
+            </a:r>
+          </a:p>
+          <a:p>
+            <a:pPr marL="514350" indent="-514350">
+              <a:buAutoNum type="arabicPeriod"/>
+            </a:pPr>
+            <a:endParaRPr lang="en-CA" dirty="0"/>
+          </a:p>
+          <a:p>
+            <a:pPr marL="0" indent="0">
+              <a:buNone/>
+            </a:pPr>
+            <a:r>
+              <a:rPr lang="en-CA" dirty="0"/>
+              <a:t>2. Booking horizon</a:t>
+            </a:r>
+          </a:p>
+          <a:p>
+            <a:pPr lvl="1"/>
+            <a:r>
+              <a:rPr lang="en-CA" dirty="0"/>
+              <a:t>Adjusting how early an appointment booking is allowed.</a:t>
+            </a:r>
+          </a:p>
+        </p:txBody>
+      </p:sp>
+      <p:cxnSp>
+        <p:nvCxnSpPr>
+          <p:cNvPr id="4" name="Straight Connector 3">
+            <a:extLst>
+              <a:ext uri="{FF2B5EF4-FFF2-40B4-BE49-F238E27FC236}">
+                <a16:creationId xmlns:a16="http://schemas.microsoft.com/office/drawing/2014/main" id="{3784AF40-FCDC-49B4-8EEC-D83A493E2ADF}"/>
+              </a:ext>
+            </a:extLst>
+          </p:cNvPr>
+          <p:cNvCxnSpPr>
+            <a:cxnSpLocks/>
+          </p:cNvCxnSpPr>
+          <p:nvPr/>
+        </p:nvCxnSpPr>
+        <p:spPr>
+          <a:xfrm>
+            <a:off x="698879" y="1399115"/>
+            <a:ext cx="10794242" cy="0"/>
+          </a:xfrm>
+          <a:prstGeom prst="line">
+            <a:avLst/>
+          </a:prstGeom>
+          <a:ln w="28575">
+            <a:solidFill>
+              <a:schemeClr val="accent5"/>
+            </a:solidFill>
+          </a:ln>
+        </p:spPr>
+        <p:style>
+          <a:lnRef idx="1">
+            <a:schemeClr val="accent1"/>
+          </a:lnRef>
+          <a:fillRef idx="0">
+            <a:schemeClr val="accent1"/>
+          </a:fillRef>
+          <a:effectRef idx="0">
+            <a:schemeClr val="accent1"/>
+          </a:effectRef>
+          <a:fontRef idx="minor">
+            <a:schemeClr val="tx1"/>
+          </a:fontRef>
+        </p:style>
+      </p:cxnSp>
+    </p:spTree>
+    <p:extLst>
+      <p:ext uri="{BB962C8B-B14F-4D97-AF65-F5344CB8AC3E}">
+        <p14:creationId xmlns:p14="http://schemas.microsoft.com/office/powerpoint/2010/main" val="4244925151"/>
       </p:ext>
     </p:extLst>
   </p:cSld>
@@ -5064,7 +5733,7 @@
             </a:pPr>
             <a:r>
               <a:rPr lang="en-CA" dirty="0"/>
-              <a:t>The patient is offered an appointment, but decides to not take it because the wait is too long.</a:t>
+              <a:t>The patient is offered an appointment, but decides to not show-up because the wait is too long.</a:t>
             </a:r>
             <a:endParaRPr lang="en-CA" sz="3200" dirty="0"/>
           </a:p>
@@ -5869,6 +6538,98 @@
           <p:cNvPr id="2" name="Title 1">
             <a:extLst>
               <a:ext uri="{FF2B5EF4-FFF2-40B4-BE49-F238E27FC236}">
+                <a16:creationId xmlns:a16="http://schemas.microsoft.com/office/drawing/2014/main" id="{A21633CC-5640-40DD-82F7-8C55D31A5E8D}"/>
+              </a:ext>
+            </a:extLst>
+          </p:cNvPr>
+          <p:cNvSpPr>
+            <a:spLocks noGrp="1"/>
+          </p:cNvSpPr>
+          <p:nvPr>
+            <p:ph type="title"/>
+          </p:nvPr>
+        </p:nvSpPr>
+        <p:spPr/>
+        <p:txBody>
+          <a:bodyPr/>
+          <a:lstStyle/>
+          <a:p>
+            <a:r>
+              <a:rPr lang="en-CA" dirty="0"/>
+              <a:t>Threshold mechanisms: magnitude and delay </a:t>
+            </a:r>
+          </a:p>
+        </p:txBody>
+      </p:sp>
+      <p:sp>
+        <p:nvSpPr>
+          <p:cNvPr id="3" name="Content Placeholder 2">
+            <a:extLst>
+              <a:ext uri="{FF2B5EF4-FFF2-40B4-BE49-F238E27FC236}">
+                <a16:creationId xmlns:a16="http://schemas.microsoft.com/office/drawing/2014/main" id="{F4D00A5A-4B37-44F0-B338-F679E868F683}"/>
+              </a:ext>
+            </a:extLst>
+          </p:cNvPr>
+          <p:cNvSpPr>
+            <a:spLocks noGrp="1"/>
+          </p:cNvSpPr>
+          <p:nvPr>
+            <p:ph idx="1"/>
+          </p:nvPr>
+        </p:nvSpPr>
+        <p:spPr/>
+        <p:txBody>
+          <a:bodyPr/>
+          <a:lstStyle/>
+          <a:p>
+            <a:r>
+              <a:rPr lang="en-CA" dirty="0"/>
+              <a:t>For both no-show and balking behavior of both classes</a:t>
+            </a:r>
+          </a:p>
+          <a:p>
+            <a:r>
+              <a:rPr lang="en-CA" dirty="0"/>
+              <a:t>Magnitude and delay for probability and threshold</a:t>
+            </a:r>
+          </a:p>
+        </p:txBody>
+      </p:sp>
+    </p:spTree>
+    <p:extLst>
+      <p:ext uri="{BB962C8B-B14F-4D97-AF65-F5344CB8AC3E}">
+        <p14:creationId xmlns:p14="http://schemas.microsoft.com/office/powerpoint/2010/main" val="2806244447"/>
+      </p:ext>
+    </p:extLst>
+  </p:cSld>
+  <p:clrMapOvr>
+    <a:masterClrMapping/>
+  </p:clrMapOvr>
+</p:sld>
+</file>
+
+<file path=ppt/slides/slide7.xml><?xml version="1.0" encoding="utf-8"?>
+<p:sld xmlns:a="http://schemas.openxmlformats.org/drawingml/2006/main" xmlns:r="http://schemas.openxmlformats.org/officeDocument/2006/relationships" xmlns:p="http://schemas.openxmlformats.org/presentationml/2006/main">
+  <p:cSld>
+    <p:spTree>
+      <p:nvGrpSpPr>
+        <p:cNvPr id="1" name=""/>
+        <p:cNvGrpSpPr/>
+        <p:nvPr/>
+      </p:nvGrpSpPr>
+      <p:grpSpPr>
+        <a:xfrm>
+          <a:off x="0" y="0"/>
+          <a:ext cx="0" cy="0"/>
+          <a:chOff x="0" y="0"/>
+          <a:chExt cx="0" cy="0"/>
+        </a:xfrm>
+      </p:grpSpPr>
+      <p:sp>
+        <p:nvSpPr>
+          <p:cNvPr id="2" name="Title 1">
+            <a:extLst>
+              <a:ext uri="{FF2B5EF4-FFF2-40B4-BE49-F238E27FC236}">
                 <a16:creationId xmlns:a16="http://schemas.microsoft.com/office/drawing/2014/main" id="{A2B96ABB-6D63-436C-B8C2-BB1B556FC08F}"/>
               </a:ext>
             </a:extLst>
@@ -5894,7 +6655,7 @@
           <a:p>
             <a:r>
               <a:rPr lang="en-CA" sz="4000" dirty="0"/>
-              <a:t>Under heavy demand, balking shifts appointments to the more wait-tolerant group</a:t>
+              <a:t>Under heavy demand, balking magnitude shifts appointments to the more wait-tolerant group</a:t>
             </a:r>
           </a:p>
         </p:txBody>
@@ -5915,8 +6676,8 @@
         </p:nvSpPr>
         <p:spPr>
           <a:xfrm>
-            <a:off x="1699068" y="5540207"/>
-            <a:ext cx="10130330" cy="922216"/>
+            <a:off x="975444" y="5578166"/>
+            <a:ext cx="10832711" cy="922216"/>
           </a:xfrm>
           <a:prstGeom prst="rect">
             <a:avLst/>
@@ -5924,7 +6685,7 @@
         </p:spPr>
         <p:txBody>
           <a:bodyPr vert="horz" lIns="91440" tIns="45720" rIns="91440" bIns="45720" rtlCol="0">
-            <a:normAutofit lnSpcReduction="10000"/>
+            <a:normAutofit fontScale="92500" lnSpcReduction="10000"/>
           </a:bodyPr>
           <a:lstStyle>
             <a:lvl1pPr marL="228600" indent="-228600" algn="l" defTabSz="914400" rtl="0" eaLnBrk="1" latinLnBrk="0" hangingPunct="1">
@@ -6093,7 +6854,7 @@
           <a:p>
             <a:r>
               <a:rPr lang="en-CA" dirty="0"/>
-              <a:t>Utilization and served rate is not impacted by balking. </a:t>
+              <a:t>Overall utilization and served rate is not impacted by balking magnitude.</a:t>
             </a:r>
           </a:p>
           <a:p>
@@ -6187,7 +6948,7 @@
 </p:sld>
 </file>
 
-<file path=ppt/slides/slide7.xml><?xml version="1.0" encoding="utf-8"?>
+<file path=ppt/slides/slide8.xml><?xml version="1.0" encoding="utf-8"?>
 <p:sld xmlns:a="http://schemas.openxmlformats.org/drawingml/2006/main" xmlns:r="http://schemas.openxmlformats.org/officeDocument/2006/relationships" xmlns:p="http://schemas.openxmlformats.org/presentationml/2006/main">
   <p:cSld>
     <p:spTree>
@@ -6220,7 +6981,12 @@
             <p:ph type="title"/>
           </p:nvPr>
         </p:nvSpPr>
-        <p:spPr/>
+        <p:spPr>
+          <a:xfrm>
+            <a:off x="838200" y="335144"/>
+            <a:ext cx="10515600" cy="1325563"/>
+          </a:xfrm>
+        </p:spPr>
         <p:txBody>
           <a:bodyPr>
             <a:normAutofit/>
@@ -6271,19 +7037,19 @@
             </a:r>
             <a:r>
               <a:rPr lang="en-CA" sz="2400" b="1" dirty="0"/>
-              <a:t>probability</a:t>
+              <a:t>magnitude</a:t>
             </a:r>
             <a:r>
               <a:rPr lang="en-CA" sz="2400" dirty="0"/>
-              <a:t> of no-show and balking, </a:t>
+              <a:t> of no-show and balking, the</a:t>
             </a:r>
             <a:r>
               <a:rPr lang="en-CA" sz="2400" b="1" dirty="0"/>
-              <a:t>when</a:t>
+              <a:t> delay </a:t>
             </a:r>
             <a:r>
               <a:rPr lang="en-CA" sz="2400" dirty="0"/>
-              <a:t> those behaviors begin also matters.</a:t>
+              <a:t>also matters.</a:t>
             </a:r>
           </a:p>
           <a:p>
@@ -6314,16 +7080,15 @@
           </p:cNvPicPr>
           <p:nvPr/>
         </p:nvPicPr>
-        <p:blipFill>
+        <p:blipFill rotWithShape="1">
           <a:blip r:embed="rId2"/>
-          <a:stretch>
-            <a:fillRect/>
-          </a:stretch>
+          <a:srcRect t="6612"/>
+          <a:stretch/>
         </p:blipFill>
         <p:spPr>
           <a:xfrm>
-            <a:off x="548333" y="1985935"/>
-            <a:ext cx="5130379" cy="3291187"/>
+            <a:off x="485496" y="2094534"/>
+            <a:ext cx="5380594" cy="3223470"/>
           </a:xfrm>
           <a:prstGeom prst="rect">
             <a:avLst/>
@@ -6344,155 +7109,429 @@
           </p:cNvPicPr>
           <p:nvPr/>
         </p:nvPicPr>
-        <p:blipFill>
+        <p:blipFill rotWithShape="1">
           <a:blip r:embed="rId3"/>
-          <a:stretch>
-            <a:fillRect/>
-          </a:stretch>
+          <a:srcRect t="6997"/>
+          <a:stretch/>
         </p:blipFill>
         <p:spPr>
           <a:xfrm>
-            <a:off x="6096000" y="1945052"/>
-            <a:ext cx="5130380" cy="3372952"/>
+            <a:off x="6096000" y="2058056"/>
+            <a:ext cx="5380594" cy="3289927"/>
           </a:xfrm>
           <a:prstGeom prst="rect">
             <a:avLst/>
           </a:prstGeom>
         </p:spPr>
       </p:pic>
-    </p:spTree>
-    <p:extLst>
-      <p:ext uri="{BB962C8B-B14F-4D97-AF65-F5344CB8AC3E}">
-        <p14:creationId xmlns:p14="http://schemas.microsoft.com/office/powerpoint/2010/main" val="3281064396"/>
-      </p:ext>
-    </p:extLst>
-  </p:cSld>
-  <p:clrMapOvr>
-    <a:masterClrMapping/>
-  </p:clrMapOvr>
-</p:sld>
-</file>
-
-<file path=ppt/slides/slide8.xml><?xml version="1.0" encoding="utf-8"?>
-<p:sld xmlns:a="http://schemas.openxmlformats.org/drawingml/2006/main" xmlns:r="http://schemas.openxmlformats.org/officeDocument/2006/relationships" xmlns:p="http://schemas.openxmlformats.org/presentationml/2006/main">
-  <p:cSld>
-    <p:spTree>
-      <p:nvGrpSpPr>
-        <p:cNvPr id="1" name=""/>
-        <p:cNvGrpSpPr/>
-        <p:nvPr/>
-      </p:nvGrpSpPr>
-      <p:grpSpPr>
-        <a:xfrm>
-          <a:off x="0" y="0"/>
-          <a:ext cx="0" cy="0"/>
-          <a:chOff x="0" y="0"/>
-          <a:chExt cx="0" cy="0"/>
-        </a:xfrm>
-      </p:grpSpPr>
-      <p:sp>
-        <p:nvSpPr>
-          <p:cNvPr id="2" name="Title 1">
+      <p:sp>
+        <p:nvSpPr>
+          <p:cNvPr id="6" name="Content Placeholder 2">
             <a:extLst>
               <a:ext uri="{FF2B5EF4-FFF2-40B4-BE49-F238E27FC236}">
-                <a16:creationId xmlns:a16="http://schemas.microsoft.com/office/drawing/2014/main" id="{ED0526D7-4325-4EAD-83C4-EFAEFFC15851}"/>
+                <a16:creationId xmlns:a16="http://schemas.microsoft.com/office/drawing/2014/main" id="{21956235-D240-493B-B123-002E69B01EB2}"/>
               </a:ext>
             </a:extLst>
           </p:cNvPr>
-          <p:cNvSpPr>
-            <a:spLocks noGrp="1"/>
-          </p:cNvSpPr>
-          <p:nvPr>
-            <p:ph type="title"/>
-          </p:nvPr>
-        </p:nvSpPr>
-        <p:spPr/>
-        <p:txBody>
-          <a:bodyPr>
-            <a:normAutofit/>
-          </a:bodyPr>
-          <a:lstStyle/>
-          <a:p>
-            <a:r>
-              <a:rPr lang="en-CA" dirty="0"/>
-              <a:t>Balking is a stronger driver of class access than no-show**</a:t>
-            </a:r>
-          </a:p>
-        </p:txBody>
-      </p:sp>
-      <p:sp>
-        <p:nvSpPr>
-          <p:cNvPr id="12" name="Content Placeholder 11">
-            <a:extLst>
-              <a:ext uri="{FF2B5EF4-FFF2-40B4-BE49-F238E27FC236}">
-                <a16:creationId xmlns:a16="http://schemas.microsoft.com/office/drawing/2014/main" id="{CA86EA13-5E32-4D1B-B846-A0EA7161B278}"/>
-              </a:ext>
-            </a:extLst>
-          </p:cNvPr>
-          <p:cNvSpPr>
-            <a:spLocks noGrp="1"/>
-          </p:cNvSpPr>
-          <p:nvPr>
-            <p:ph idx="1"/>
-          </p:nvPr>
+          <p:cNvSpPr txBox="1">
+            <a:spLocks/>
+          </p:cNvSpPr>
+          <p:nvPr/>
         </p:nvSpPr>
         <p:spPr>
           <a:xfrm>
-            <a:off x="1437799" y="1885292"/>
-            <a:ext cx="8964246" cy="1111005"/>
-          </a:xfrm>
-        </p:spPr>
-        <p:txBody>
-          <a:bodyPr>
-            <a:normAutofit/>
-          </a:bodyPr>
-          <a:lstStyle/>
-          <a:p>
-            <a:pPr marL="0" indent="0">
-              <a:buFont typeface="Arial" panose="020B0604020202020204" pitchFamily="34" charset="0"/>
-              <a:buNone/>
-            </a:pPr>
-            <a:r>
-              <a:rPr lang="en-CA" sz="2000" dirty="0"/>
-              <a:t>In the standardized regression, between-class differences in balking were more strongly associated with the served-rate gap than between-class differences in no-show behavior.</a:t>
-            </a:r>
-          </a:p>
-        </p:txBody>
-      </p:sp>
-      <p:pic>
-        <p:nvPicPr>
-          <p:cNvPr id="14" name="Picture 13">
-            <a:extLst>
-              <a:ext uri="{FF2B5EF4-FFF2-40B4-BE49-F238E27FC236}">
-                <a16:creationId xmlns:a16="http://schemas.microsoft.com/office/drawing/2014/main" id="{5259B7A1-D828-48EB-A036-2FA2942A7916}"/>
-              </a:ext>
-            </a:extLst>
-          </p:cNvPr>
-          <p:cNvPicPr>
-            <a:picLocks noChangeAspect="1"/>
-          </p:cNvPicPr>
-          <p:nvPr/>
-        </p:nvPicPr>
-        <p:blipFill>
-          <a:blip r:embed="rId2"/>
-          <a:stretch>
-            <a:fillRect/>
-          </a:stretch>
-        </p:blipFill>
-        <p:spPr>
-          <a:xfrm>
-            <a:off x="2597513" y="2912620"/>
-            <a:ext cx="5319472" cy="3331871"/>
+            <a:off x="7814813" y="1660707"/>
+            <a:ext cx="2618342" cy="662742"/>
           </a:xfrm>
           <a:prstGeom prst="rect">
             <a:avLst/>
           </a:prstGeom>
         </p:spPr>
-      </p:pic>
+        <p:txBody>
+          <a:bodyPr vert="horz" lIns="91440" tIns="45720" rIns="91440" bIns="45720" rtlCol="0">
+            <a:normAutofit/>
+          </a:bodyPr>
+          <a:lstStyle>
+            <a:lvl1pPr marL="228600" indent="-228600" algn="l" defTabSz="914400" rtl="0" eaLnBrk="1" latinLnBrk="0" hangingPunct="1">
+              <a:lnSpc>
+                <a:spcPct val="90000"/>
+              </a:lnSpc>
+              <a:spcBef>
+                <a:spcPts val="1000"/>
+              </a:spcBef>
+              <a:buFont typeface="Arial" panose="020B0604020202020204" pitchFamily="34" charset="0"/>
+              <a:buChar char="•"/>
+              <a:defRPr sz="2800" kern="1200">
+                <a:solidFill>
+                  <a:schemeClr val="tx1"/>
+                </a:solidFill>
+                <a:latin typeface="+mn-lt"/>
+                <a:ea typeface="+mn-ea"/>
+                <a:cs typeface="+mn-cs"/>
+              </a:defRPr>
+            </a:lvl1pPr>
+            <a:lvl2pPr marL="685800" indent="-228600" algn="l" defTabSz="914400" rtl="0" eaLnBrk="1" latinLnBrk="0" hangingPunct="1">
+              <a:lnSpc>
+                <a:spcPct val="90000"/>
+              </a:lnSpc>
+              <a:spcBef>
+                <a:spcPts val="500"/>
+              </a:spcBef>
+              <a:buFont typeface="Arial" panose="020B0604020202020204" pitchFamily="34" charset="0"/>
+              <a:buChar char="•"/>
+              <a:defRPr sz="2400" kern="1200">
+                <a:solidFill>
+                  <a:schemeClr val="tx1"/>
+                </a:solidFill>
+                <a:latin typeface="+mn-lt"/>
+                <a:ea typeface="+mn-ea"/>
+                <a:cs typeface="+mn-cs"/>
+              </a:defRPr>
+            </a:lvl2pPr>
+            <a:lvl3pPr marL="1143000" indent="-228600" algn="l" defTabSz="914400" rtl="0" eaLnBrk="1" latinLnBrk="0" hangingPunct="1">
+              <a:lnSpc>
+                <a:spcPct val="90000"/>
+              </a:lnSpc>
+              <a:spcBef>
+                <a:spcPts val="500"/>
+              </a:spcBef>
+              <a:buFont typeface="Arial" panose="020B0604020202020204" pitchFamily="34" charset="0"/>
+              <a:buChar char="•"/>
+              <a:defRPr sz="2000" kern="1200">
+                <a:solidFill>
+                  <a:schemeClr val="tx1"/>
+                </a:solidFill>
+                <a:latin typeface="+mn-lt"/>
+                <a:ea typeface="+mn-ea"/>
+                <a:cs typeface="+mn-cs"/>
+              </a:defRPr>
+            </a:lvl3pPr>
+            <a:lvl4pPr marL="1600200" indent="-228600" algn="l" defTabSz="914400" rtl="0" eaLnBrk="1" latinLnBrk="0" hangingPunct="1">
+              <a:lnSpc>
+                <a:spcPct val="90000"/>
+              </a:lnSpc>
+              <a:spcBef>
+                <a:spcPts val="500"/>
+              </a:spcBef>
+              <a:buFont typeface="Arial" panose="020B0604020202020204" pitchFamily="34" charset="0"/>
+              <a:buChar char="•"/>
+              <a:defRPr sz="1800" kern="1200">
+                <a:solidFill>
+                  <a:schemeClr val="tx1"/>
+                </a:solidFill>
+                <a:latin typeface="+mn-lt"/>
+                <a:ea typeface="+mn-ea"/>
+                <a:cs typeface="+mn-cs"/>
+              </a:defRPr>
+            </a:lvl4pPr>
+            <a:lvl5pPr marL="2057400" indent="-228600" algn="l" defTabSz="914400" rtl="0" eaLnBrk="1" latinLnBrk="0" hangingPunct="1">
+              <a:lnSpc>
+                <a:spcPct val="90000"/>
+              </a:lnSpc>
+              <a:spcBef>
+                <a:spcPts val="500"/>
+              </a:spcBef>
+              <a:buFont typeface="Arial" panose="020B0604020202020204" pitchFamily="34" charset="0"/>
+              <a:buChar char="•"/>
+              <a:defRPr sz="1800" kern="1200">
+                <a:solidFill>
+                  <a:schemeClr val="tx1"/>
+                </a:solidFill>
+                <a:latin typeface="+mn-lt"/>
+                <a:ea typeface="+mn-ea"/>
+                <a:cs typeface="+mn-cs"/>
+              </a:defRPr>
+            </a:lvl5pPr>
+            <a:lvl6pPr marL="2514600" indent="-228600" algn="l" defTabSz="914400" rtl="0" eaLnBrk="1" latinLnBrk="0" hangingPunct="1">
+              <a:lnSpc>
+                <a:spcPct val="90000"/>
+              </a:lnSpc>
+              <a:spcBef>
+                <a:spcPts val="500"/>
+              </a:spcBef>
+              <a:buFont typeface="Arial" panose="020B0604020202020204" pitchFamily="34" charset="0"/>
+              <a:buChar char="•"/>
+              <a:defRPr sz="1800" kern="1200">
+                <a:solidFill>
+                  <a:schemeClr val="tx1"/>
+                </a:solidFill>
+                <a:latin typeface="+mn-lt"/>
+                <a:ea typeface="+mn-ea"/>
+                <a:cs typeface="+mn-cs"/>
+              </a:defRPr>
+            </a:lvl6pPr>
+            <a:lvl7pPr marL="2971800" indent="-228600" algn="l" defTabSz="914400" rtl="0" eaLnBrk="1" latinLnBrk="0" hangingPunct="1">
+              <a:lnSpc>
+                <a:spcPct val="90000"/>
+              </a:lnSpc>
+              <a:spcBef>
+                <a:spcPts val="500"/>
+              </a:spcBef>
+              <a:buFont typeface="Arial" panose="020B0604020202020204" pitchFamily="34" charset="0"/>
+              <a:buChar char="•"/>
+              <a:defRPr sz="1800" kern="1200">
+                <a:solidFill>
+                  <a:schemeClr val="tx1"/>
+                </a:solidFill>
+                <a:latin typeface="+mn-lt"/>
+                <a:ea typeface="+mn-ea"/>
+                <a:cs typeface="+mn-cs"/>
+              </a:defRPr>
+            </a:lvl7pPr>
+            <a:lvl8pPr marL="3429000" indent="-228600" algn="l" defTabSz="914400" rtl="0" eaLnBrk="1" latinLnBrk="0" hangingPunct="1">
+              <a:lnSpc>
+                <a:spcPct val="90000"/>
+              </a:lnSpc>
+              <a:spcBef>
+                <a:spcPts val="500"/>
+              </a:spcBef>
+              <a:buFont typeface="Arial" panose="020B0604020202020204" pitchFamily="34" charset="0"/>
+              <a:buChar char="•"/>
+              <a:defRPr sz="1800" kern="1200">
+                <a:solidFill>
+                  <a:schemeClr val="tx1"/>
+                </a:solidFill>
+                <a:latin typeface="+mn-lt"/>
+                <a:ea typeface="+mn-ea"/>
+                <a:cs typeface="+mn-cs"/>
+              </a:defRPr>
+            </a:lvl8pPr>
+            <a:lvl9pPr marL="3886200" indent="-228600" algn="l" defTabSz="914400" rtl="0" eaLnBrk="1" latinLnBrk="0" hangingPunct="1">
+              <a:lnSpc>
+                <a:spcPct val="90000"/>
+              </a:lnSpc>
+              <a:spcBef>
+                <a:spcPts val="500"/>
+              </a:spcBef>
+              <a:buFont typeface="Arial" panose="020B0604020202020204" pitchFamily="34" charset="0"/>
+              <a:buChar char="•"/>
+              <a:defRPr sz="1800" kern="1200">
+                <a:solidFill>
+                  <a:schemeClr val="tx1"/>
+                </a:solidFill>
+                <a:latin typeface="+mn-lt"/>
+                <a:ea typeface="+mn-ea"/>
+                <a:cs typeface="+mn-cs"/>
+              </a:defRPr>
+            </a:lvl9pPr>
+          </a:lstStyle>
+          <a:p>
+            <a:pPr marL="0" indent="0">
+              <a:buNone/>
+            </a:pPr>
+            <a:r>
+              <a:rPr lang="en-CA" sz="1800" dirty="0"/>
+              <a:t>Delay – threshold</a:t>
+            </a:r>
+          </a:p>
+        </p:txBody>
+      </p:sp>
+      <p:sp>
+        <p:nvSpPr>
+          <p:cNvPr id="8" name="Content Placeholder 2">
+            <a:extLst>
+              <a:ext uri="{FF2B5EF4-FFF2-40B4-BE49-F238E27FC236}">
+                <a16:creationId xmlns:a16="http://schemas.microsoft.com/office/drawing/2014/main" id="{BB61C4F8-76CE-4AAA-9256-D4F8DD4F59FA}"/>
+              </a:ext>
+            </a:extLst>
+          </p:cNvPr>
+          <p:cNvSpPr txBox="1">
+            <a:spLocks/>
+          </p:cNvSpPr>
+          <p:nvPr/>
+        </p:nvSpPr>
+        <p:spPr>
+          <a:xfrm>
+            <a:off x="1284158" y="1726685"/>
+            <a:ext cx="3891197" cy="662742"/>
+          </a:xfrm>
+          <a:prstGeom prst="rect">
+            <a:avLst/>
+          </a:prstGeom>
+        </p:spPr>
+        <p:txBody>
+          <a:bodyPr vert="horz" lIns="91440" tIns="45720" rIns="91440" bIns="45720" rtlCol="0">
+            <a:normAutofit/>
+          </a:bodyPr>
+          <a:lstStyle>
+            <a:lvl1pPr marL="228600" indent="-228600" algn="l" defTabSz="914400" rtl="0" eaLnBrk="1" latinLnBrk="0" hangingPunct="1">
+              <a:lnSpc>
+                <a:spcPct val="90000"/>
+              </a:lnSpc>
+              <a:spcBef>
+                <a:spcPts val="1000"/>
+              </a:spcBef>
+              <a:buFont typeface="Arial" panose="020B0604020202020204" pitchFamily="34" charset="0"/>
+              <a:buChar char="•"/>
+              <a:defRPr sz="2800" kern="1200">
+                <a:solidFill>
+                  <a:schemeClr val="tx1"/>
+                </a:solidFill>
+                <a:latin typeface="+mn-lt"/>
+                <a:ea typeface="+mn-ea"/>
+                <a:cs typeface="+mn-cs"/>
+              </a:defRPr>
+            </a:lvl1pPr>
+            <a:lvl2pPr marL="685800" indent="-228600" algn="l" defTabSz="914400" rtl="0" eaLnBrk="1" latinLnBrk="0" hangingPunct="1">
+              <a:lnSpc>
+                <a:spcPct val="90000"/>
+              </a:lnSpc>
+              <a:spcBef>
+                <a:spcPts val="500"/>
+              </a:spcBef>
+              <a:buFont typeface="Arial" panose="020B0604020202020204" pitchFamily="34" charset="0"/>
+              <a:buChar char="•"/>
+              <a:defRPr sz="2400" kern="1200">
+                <a:solidFill>
+                  <a:schemeClr val="tx1"/>
+                </a:solidFill>
+                <a:latin typeface="+mn-lt"/>
+                <a:ea typeface="+mn-ea"/>
+                <a:cs typeface="+mn-cs"/>
+              </a:defRPr>
+            </a:lvl2pPr>
+            <a:lvl3pPr marL="1143000" indent="-228600" algn="l" defTabSz="914400" rtl="0" eaLnBrk="1" latinLnBrk="0" hangingPunct="1">
+              <a:lnSpc>
+                <a:spcPct val="90000"/>
+              </a:lnSpc>
+              <a:spcBef>
+                <a:spcPts val="500"/>
+              </a:spcBef>
+              <a:buFont typeface="Arial" panose="020B0604020202020204" pitchFamily="34" charset="0"/>
+              <a:buChar char="•"/>
+              <a:defRPr sz="2000" kern="1200">
+                <a:solidFill>
+                  <a:schemeClr val="tx1"/>
+                </a:solidFill>
+                <a:latin typeface="+mn-lt"/>
+                <a:ea typeface="+mn-ea"/>
+                <a:cs typeface="+mn-cs"/>
+              </a:defRPr>
+            </a:lvl3pPr>
+            <a:lvl4pPr marL="1600200" indent="-228600" algn="l" defTabSz="914400" rtl="0" eaLnBrk="1" latinLnBrk="0" hangingPunct="1">
+              <a:lnSpc>
+                <a:spcPct val="90000"/>
+              </a:lnSpc>
+              <a:spcBef>
+                <a:spcPts val="500"/>
+              </a:spcBef>
+              <a:buFont typeface="Arial" panose="020B0604020202020204" pitchFamily="34" charset="0"/>
+              <a:buChar char="•"/>
+              <a:defRPr sz="1800" kern="1200">
+                <a:solidFill>
+                  <a:schemeClr val="tx1"/>
+                </a:solidFill>
+                <a:latin typeface="+mn-lt"/>
+                <a:ea typeface="+mn-ea"/>
+                <a:cs typeface="+mn-cs"/>
+              </a:defRPr>
+            </a:lvl4pPr>
+            <a:lvl5pPr marL="2057400" indent="-228600" algn="l" defTabSz="914400" rtl="0" eaLnBrk="1" latinLnBrk="0" hangingPunct="1">
+              <a:lnSpc>
+                <a:spcPct val="90000"/>
+              </a:lnSpc>
+              <a:spcBef>
+                <a:spcPts val="500"/>
+              </a:spcBef>
+              <a:buFont typeface="Arial" panose="020B0604020202020204" pitchFamily="34" charset="0"/>
+              <a:buChar char="•"/>
+              <a:defRPr sz="1800" kern="1200">
+                <a:solidFill>
+                  <a:schemeClr val="tx1"/>
+                </a:solidFill>
+                <a:latin typeface="+mn-lt"/>
+                <a:ea typeface="+mn-ea"/>
+                <a:cs typeface="+mn-cs"/>
+              </a:defRPr>
+            </a:lvl5pPr>
+            <a:lvl6pPr marL="2514600" indent="-228600" algn="l" defTabSz="914400" rtl="0" eaLnBrk="1" latinLnBrk="0" hangingPunct="1">
+              <a:lnSpc>
+                <a:spcPct val="90000"/>
+              </a:lnSpc>
+              <a:spcBef>
+                <a:spcPts val="500"/>
+              </a:spcBef>
+              <a:buFont typeface="Arial" panose="020B0604020202020204" pitchFamily="34" charset="0"/>
+              <a:buChar char="•"/>
+              <a:defRPr sz="1800" kern="1200">
+                <a:solidFill>
+                  <a:schemeClr val="tx1"/>
+                </a:solidFill>
+                <a:latin typeface="+mn-lt"/>
+                <a:ea typeface="+mn-ea"/>
+                <a:cs typeface="+mn-cs"/>
+              </a:defRPr>
+            </a:lvl6pPr>
+            <a:lvl7pPr marL="2971800" indent="-228600" algn="l" defTabSz="914400" rtl="0" eaLnBrk="1" latinLnBrk="0" hangingPunct="1">
+              <a:lnSpc>
+                <a:spcPct val="90000"/>
+              </a:lnSpc>
+              <a:spcBef>
+                <a:spcPts val="500"/>
+              </a:spcBef>
+              <a:buFont typeface="Arial" panose="020B0604020202020204" pitchFamily="34" charset="0"/>
+              <a:buChar char="•"/>
+              <a:defRPr sz="1800" kern="1200">
+                <a:solidFill>
+                  <a:schemeClr val="tx1"/>
+                </a:solidFill>
+                <a:latin typeface="+mn-lt"/>
+                <a:ea typeface="+mn-ea"/>
+                <a:cs typeface="+mn-cs"/>
+              </a:defRPr>
+            </a:lvl7pPr>
+            <a:lvl8pPr marL="3429000" indent="-228600" algn="l" defTabSz="914400" rtl="0" eaLnBrk="1" latinLnBrk="0" hangingPunct="1">
+              <a:lnSpc>
+                <a:spcPct val="90000"/>
+              </a:lnSpc>
+              <a:spcBef>
+                <a:spcPts val="500"/>
+              </a:spcBef>
+              <a:buFont typeface="Arial" panose="020B0604020202020204" pitchFamily="34" charset="0"/>
+              <a:buChar char="•"/>
+              <a:defRPr sz="1800" kern="1200">
+                <a:solidFill>
+                  <a:schemeClr val="tx1"/>
+                </a:solidFill>
+                <a:latin typeface="+mn-lt"/>
+                <a:ea typeface="+mn-ea"/>
+                <a:cs typeface="+mn-cs"/>
+              </a:defRPr>
+            </a:lvl8pPr>
+            <a:lvl9pPr marL="3886200" indent="-228600" algn="l" defTabSz="914400" rtl="0" eaLnBrk="1" latinLnBrk="0" hangingPunct="1">
+              <a:lnSpc>
+                <a:spcPct val="90000"/>
+              </a:lnSpc>
+              <a:spcBef>
+                <a:spcPts val="500"/>
+              </a:spcBef>
+              <a:buFont typeface="Arial" panose="020B0604020202020204" pitchFamily="34" charset="0"/>
+              <a:buChar char="•"/>
+              <a:defRPr sz="1800" kern="1200">
+                <a:solidFill>
+                  <a:schemeClr val="tx1"/>
+                </a:solidFill>
+                <a:latin typeface="+mn-lt"/>
+                <a:ea typeface="+mn-ea"/>
+                <a:cs typeface="+mn-cs"/>
+              </a:defRPr>
+            </a:lvl9pPr>
+          </a:lstStyle>
+          <a:p>
+            <a:pPr marL="0" indent="0">
+              <a:buNone/>
+            </a:pPr>
+            <a:r>
+              <a:rPr lang="en-CA" sz="1800" dirty="0"/>
+              <a:t>Magnitude – post threshold probability</a:t>
+            </a:r>
+          </a:p>
+        </p:txBody>
+      </p:sp>
     </p:spTree>
     <p:extLst>
       <p:ext uri="{BB962C8B-B14F-4D97-AF65-F5344CB8AC3E}">
-        <p14:creationId xmlns:p14="http://schemas.microsoft.com/office/powerpoint/2010/main" val="103113034"/>
+        <p14:creationId xmlns:p14="http://schemas.microsoft.com/office/powerpoint/2010/main" val="3281064396"/>
       </p:ext>
     </p:extLst>
   </p:cSld>
@@ -6524,7 +7563,7 @@
           <p:cNvPr id="2" name="Title 1">
             <a:extLst>
               <a:ext uri="{FF2B5EF4-FFF2-40B4-BE49-F238E27FC236}">
-                <a16:creationId xmlns:a16="http://schemas.microsoft.com/office/drawing/2014/main" id="{7C41D3A9-0297-4B7C-9883-BD87C6C835BB}"/>
+                <a16:creationId xmlns:a16="http://schemas.microsoft.com/office/drawing/2014/main" id="{ED0526D7-4325-4EAD-83C4-EFAEFFC15851}"/>
               </a:ext>
             </a:extLst>
           </p:cNvPr>
@@ -6537,262 +7576,83 @@
         </p:nvSpPr>
         <p:spPr>
           <a:xfrm>
-            <a:off x="838200" y="212346"/>
-            <a:ext cx="10515600" cy="1325563"/>
+            <a:off x="411078" y="282844"/>
+            <a:ext cx="11369843" cy="1325563"/>
           </a:xfrm>
         </p:spPr>
         <p:txBody>
           <a:bodyPr>
-            <a:normAutofit/>
+            <a:normAutofit fontScale="90000"/>
           </a:bodyPr>
           <a:lstStyle/>
           <a:p>
             <a:r>
-              <a:rPr lang="en-CA" sz="4000" dirty="0"/>
-              <a:t>Cancellation redistributes access and does not waste capacity</a:t>
-            </a:r>
-          </a:p>
-        </p:txBody>
-      </p:sp>
-      <p:pic>
-        <p:nvPicPr>
-          <p:cNvPr id="4" name="Content Placeholder 8">
+              <a:rPr lang="en-CA" dirty="0"/>
+              <a:t>No-show is the stronger driver of class access, but balking becomes more important as demand increases</a:t>
+            </a:r>
+          </a:p>
+        </p:txBody>
+      </p:sp>
+      <p:sp>
+        <p:nvSpPr>
+          <p:cNvPr id="4" name="Content Placeholder 3">
             <a:extLst>
               <a:ext uri="{FF2B5EF4-FFF2-40B4-BE49-F238E27FC236}">
-                <a16:creationId xmlns:a16="http://schemas.microsoft.com/office/drawing/2014/main" id="{A6C18586-3ECC-41E4-925E-079E425422DA}"/>
+                <a16:creationId xmlns:a16="http://schemas.microsoft.com/office/drawing/2014/main" id="{10B86772-9FF2-423A-B395-50D12B3A74F0}"/>
               </a:ext>
             </a:extLst>
           </p:cNvPr>
-          <p:cNvPicPr>
-            <a:picLocks noGrp="1" noChangeAspect="1"/>
-          </p:cNvPicPr>
+          <p:cNvSpPr>
+            <a:spLocks noGrp="1"/>
+          </p:cNvSpPr>
           <p:nvPr>
             <p:ph idx="1"/>
           </p:nvPr>
-        </p:nvPicPr>
-        <p:blipFill rotWithShape="1">
-          <a:blip r:embed="rId2"/>
-          <a:srcRect l="894"/>
-          <a:stretch/>
-        </p:blipFill>
+        </p:nvSpPr>
         <p:spPr>
           <a:xfrm>
-            <a:off x="439400" y="1600200"/>
-            <a:ext cx="5562009" cy="3532504"/>
+            <a:off x="8650705" y="2079523"/>
+            <a:ext cx="3130216" cy="3967316"/>
           </a:xfrm>
         </p:spPr>
-      </p:pic>
-      <p:sp>
-        <p:nvSpPr>
-          <p:cNvPr id="5" name="Content Placeholder 11">
+        <p:txBody>
+          <a:bodyPr>
+            <a:normAutofit fontScale="92500" lnSpcReduction="20000"/>
+          </a:bodyPr>
+          <a:lstStyle/>
+          <a:p>
+            <a:pPr marL="0" indent="0">
+              <a:buNone/>
+            </a:pPr>
+            <a:r>
+              <a:rPr lang="en-US" sz="2600" dirty="0"/>
+              <a:t>The served rate gap difference from making Class 1 more delay-sensitive shows opposing trends over demand.</a:t>
+            </a:r>
+          </a:p>
+          <a:p>
+            <a:pPr marL="0" indent="0">
+              <a:buNone/>
+            </a:pPr>
+            <a:endParaRPr lang="en-US" sz="2600" dirty="0"/>
+          </a:p>
+          <a:p>
+            <a:pPr marL="0" indent="0">
+              <a:buNone/>
+            </a:pPr>
+            <a:r>
+              <a:rPr lang="en-US" sz="2600" dirty="0"/>
+              <a:t>The increase in no-show magnitude of class 1 lowers served rate gap more than an identical increase in balking.</a:t>
+            </a:r>
+            <a:endParaRPr lang="en-CA" sz="2600" dirty="0"/>
+          </a:p>
+        </p:txBody>
+      </p:sp>
+      <p:pic>
+        <p:nvPicPr>
+          <p:cNvPr id="7" name="Content Placeholder 4">
             <a:extLst>
               <a:ext uri="{FF2B5EF4-FFF2-40B4-BE49-F238E27FC236}">
-                <a16:creationId xmlns:a16="http://schemas.microsoft.com/office/drawing/2014/main" id="{8300D28E-ABE5-4FED-B30F-C34DC7CD9D3A}"/>
-              </a:ext>
-            </a:extLst>
-          </p:cNvPr>
-          <p:cNvSpPr txBox="1">
-            <a:spLocks/>
-          </p:cNvSpPr>
-          <p:nvPr/>
-        </p:nvSpPr>
-        <p:spPr>
-          <a:xfrm>
-            <a:off x="782871" y="5311292"/>
-            <a:ext cx="10810033" cy="1325562"/>
-          </a:xfrm>
-          <a:prstGeom prst="rect">
-            <a:avLst/>
-          </a:prstGeom>
-        </p:spPr>
-        <p:txBody>
-          <a:bodyPr vert="horz" lIns="91440" tIns="45720" rIns="91440" bIns="45720" rtlCol="0">
-            <a:normAutofit fontScale="92500" lnSpcReduction="10000"/>
-          </a:bodyPr>
-          <a:lstStyle>
-            <a:lvl1pPr marL="228600" indent="-228600" algn="l" defTabSz="914400" rtl="0" eaLnBrk="1" latinLnBrk="0" hangingPunct="1">
-              <a:lnSpc>
-                <a:spcPct val="90000"/>
-              </a:lnSpc>
-              <a:spcBef>
-                <a:spcPts val="1000"/>
-              </a:spcBef>
-              <a:buFont typeface="Arial" panose="020B0604020202020204" pitchFamily="34" charset="0"/>
-              <a:buChar char="•"/>
-              <a:defRPr sz="2800" kern="1200">
-                <a:solidFill>
-                  <a:schemeClr val="tx1"/>
-                </a:solidFill>
-                <a:latin typeface="+mn-lt"/>
-                <a:ea typeface="+mn-ea"/>
-                <a:cs typeface="+mn-cs"/>
-              </a:defRPr>
-            </a:lvl1pPr>
-            <a:lvl2pPr marL="685800" indent="-228600" algn="l" defTabSz="914400" rtl="0" eaLnBrk="1" latinLnBrk="0" hangingPunct="1">
-              <a:lnSpc>
-                <a:spcPct val="90000"/>
-              </a:lnSpc>
-              <a:spcBef>
-                <a:spcPts val="500"/>
-              </a:spcBef>
-              <a:buFont typeface="Arial" panose="020B0604020202020204" pitchFamily="34" charset="0"/>
-              <a:buChar char="•"/>
-              <a:defRPr sz="2400" kern="1200">
-                <a:solidFill>
-                  <a:schemeClr val="tx1"/>
-                </a:solidFill>
-                <a:latin typeface="+mn-lt"/>
-                <a:ea typeface="+mn-ea"/>
-                <a:cs typeface="+mn-cs"/>
-              </a:defRPr>
-            </a:lvl2pPr>
-            <a:lvl3pPr marL="1143000" indent="-228600" algn="l" defTabSz="914400" rtl="0" eaLnBrk="1" latinLnBrk="0" hangingPunct="1">
-              <a:lnSpc>
-                <a:spcPct val="90000"/>
-              </a:lnSpc>
-              <a:spcBef>
-                <a:spcPts val="500"/>
-              </a:spcBef>
-              <a:buFont typeface="Arial" panose="020B0604020202020204" pitchFamily="34" charset="0"/>
-              <a:buChar char="•"/>
-              <a:defRPr sz="2000" kern="1200">
-                <a:solidFill>
-                  <a:schemeClr val="tx1"/>
-                </a:solidFill>
-                <a:latin typeface="+mn-lt"/>
-                <a:ea typeface="+mn-ea"/>
-                <a:cs typeface="+mn-cs"/>
-              </a:defRPr>
-            </a:lvl3pPr>
-            <a:lvl4pPr marL="1600200" indent="-228600" algn="l" defTabSz="914400" rtl="0" eaLnBrk="1" latinLnBrk="0" hangingPunct="1">
-              <a:lnSpc>
-                <a:spcPct val="90000"/>
-              </a:lnSpc>
-              <a:spcBef>
-                <a:spcPts val="500"/>
-              </a:spcBef>
-              <a:buFont typeface="Arial" panose="020B0604020202020204" pitchFamily="34" charset="0"/>
-              <a:buChar char="•"/>
-              <a:defRPr sz="1800" kern="1200">
-                <a:solidFill>
-                  <a:schemeClr val="tx1"/>
-                </a:solidFill>
-                <a:latin typeface="+mn-lt"/>
-                <a:ea typeface="+mn-ea"/>
-                <a:cs typeface="+mn-cs"/>
-              </a:defRPr>
-            </a:lvl4pPr>
-            <a:lvl5pPr marL="2057400" indent="-228600" algn="l" defTabSz="914400" rtl="0" eaLnBrk="1" latinLnBrk="0" hangingPunct="1">
-              <a:lnSpc>
-                <a:spcPct val="90000"/>
-              </a:lnSpc>
-              <a:spcBef>
-                <a:spcPts val="500"/>
-              </a:spcBef>
-              <a:buFont typeface="Arial" panose="020B0604020202020204" pitchFamily="34" charset="0"/>
-              <a:buChar char="•"/>
-              <a:defRPr sz="1800" kern="1200">
-                <a:solidFill>
-                  <a:schemeClr val="tx1"/>
-                </a:solidFill>
-                <a:latin typeface="+mn-lt"/>
-                <a:ea typeface="+mn-ea"/>
-                <a:cs typeface="+mn-cs"/>
-              </a:defRPr>
-            </a:lvl5pPr>
-            <a:lvl6pPr marL="2514600" indent="-228600" algn="l" defTabSz="914400" rtl="0" eaLnBrk="1" latinLnBrk="0" hangingPunct="1">
-              <a:lnSpc>
-                <a:spcPct val="90000"/>
-              </a:lnSpc>
-              <a:spcBef>
-                <a:spcPts val="500"/>
-              </a:spcBef>
-              <a:buFont typeface="Arial" panose="020B0604020202020204" pitchFamily="34" charset="0"/>
-              <a:buChar char="•"/>
-              <a:defRPr sz="1800" kern="1200">
-                <a:solidFill>
-                  <a:schemeClr val="tx1"/>
-                </a:solidFill>
-                <a:latin typeface="+mn-lt"/>
-                <a:ea typeface="+mn-ea"/>
-                <a:cs typeface="+mn-cs"/>
-              </a:defRPr>
-            </a:lvl6pPr>
-            <a:lvl7pPr marL="2971800" indent="-228600" algn="l" defTabSz="914400" rtl="0" eaLnBrk="1" latinLnBrk="0" hangingPunct="1">
-              <a:lnSpc>
-                <a:spcPct val="90000"/>
-              </a:lnSpc>
-              <a:spcBef>
-                <a:spcPts val="500"/>
-              </a:spcBef>
-              <a:buFont typeface="Arial" panose="020B0604020202020204" pitchFamily="34" charset="0"/>
-              <a:buChar char="•"/>
-              <a:defRPr sz="1800" kern="1200">
-                <a:solidFill>
-                  <a:schemeClr val="tx1"/>
-                </a:solidFill>
-                <a:latin typeface="+mn-lt"/>
-                <a:ea typeface="+mn-ea"/>
-                <a:cs typeface="+mn-cs"/>
-              </a:defRPr>
-            </a:lvl7pPr>
-            <a:lvl8pPr marL="3429000" indent="-228600" algn="l" defTabSz="914400" rtl="0" eaLnBrk="1" latinLnBrk="0" hangingPunct="1">
-              <a:lnSpc>
-                <a:spcPct val="90000"/>
-              </a:lnSpc>
-              <a:spcBef>
-                <a:spcPts val="500"/>
-              </a:spcBef>
-              <a:buFont typeface="Arial" panose="020B0604020202020204" pitchFamily="34" charset="0"/>
-              <a:buChar char="•"/>
-              <a:defRPr sz="1800" kern="1200">
-                <a:solidFill>
-                  <a:schemeClr val="tx1"/>
-                </a:solidFill>
-                <a:latin typeface="+mn-lt"/>
-                <a:ea typeface="+mn-ea"/>
-                <a:cs typeface="+mn-cs"/>
-              </a:defRPr>
-            </a:lvl8pPr>
-            <a:lvl9pPr marL="3886200" indent="-228600" algn="l" defTabSz="914400" rtl="0" eaLnBrk="1" latinLnBrk="0" hangingPunct="1">
-              <a:lnSpc>
-                <a:spcPct val="90000"/>
-              </a:lnSpc>
-              <a:spcBef>
-                <a:spcPts val="500"/>
-              </a:spcBef>
-              <a:buFont typeface="Arial" panose="020B0604020202020204" pitchFamily="34" charset="0"/>
-              <a:buChar char="•"/>
-              <a:defRPr sz="1800" kern="1200">
-                <a:solidFill>
-                  <a:schemeClr val="tx1"/>
-                </a:solidFill>
-                <a:latin typeface="+mn-lt"/>
-                <a:ea typeface="+mn-ea"/>
-                <a:cs typeface="+mn-cs"/>
-              </a:defRPr>
-            </a:lvl9pPr>
-          </a:lstStyle>
-          <a:p>
-            <a:r>
-              <a:rPr lang="en-CA" sz="2400" dirty="0"/>
-              <a:t>Under high demand, cancellations transfer access from one class to the other without significant pooled changes.</a:t>
-            </a:r>
-          </a:p>
-          <a:p>
-            <a:r>
-              <a:rPr lang="en-CA" sz="2400" dirty="0"/>
-              <a:t>Higher cancellation rate can improve utilization and waiting time by allowing appointments to be booked before behavior thresholds.</a:t>
-            </a:r>
-          </a:p>
-        </p:txBody>
-      </p:sp>
-      <p:pic>
-        <p:nvPicPr>
-          <p:cNvPr id="6" name="Content Placeholder 4">
-            <a:extLst>
-              <a:ext uri="{FF2B5EF4-FFF2-40B4-BE49-F238E27FC236}">
-                <a16:creationId xmlns:a16="http://schemas.microsoft.com/office/drawing/2014/main" id="{40932703-1B5B-4BE8-BB30-66B2474230B0}"/>
+                <a16:creationId xmlns:a16="http://schemas.microsoft.com/office/drawing/2014/main" id="{773CE6E8-CBA3-482B-93E3-F2E9069B1BEC}"/>
               </a:ext>
             </a:extLst>
           </p:cNvPr>
@@ -6802,15 +7662,21 @@
           <p:nvPr/>
         </p:nvPicPr>
         <p:blipFill>
-          <a:blip r:embed="rId3"/>
+          <a:blip r:embed="rId3">
+            <a:extLst>
+              <a:ext uri="{28A0092B-C50C-407E-A947-70E740481C1C}">
+                <a14:useLocalDpi xmlns:a14="http://schemas.microsoft.com/office/drawing/2010/main" val="0"/>
+              </a:ext>
+            </a:extLst>
+          </a:blip>
           <a:stretch>
             <a:fillRect/>
           </a:stretch>
         </p:blipFill>
         <p:spPr>
           <a:xfrm>
-            <a:off x="6133180" y="1600200"/>
-            <a:ext cx="5567408" cy="3532504"/>
+            <a:off x="498439" y="1727128"/>
+            <a:ext cx="7839957" cy="4613514"/>
           </a:xfrm>
           <a:prstGeom prst="rect">
             <a:avLst/>
@@ -6820,7 +7686,7 @@
     </p:spTree>
     <p:extLst>
       <p:ext uri="{BB962C8B-B14F-4D97-AF65-F5344CB8AC3E}">
-        <p14:creationId xmlns:p14="http://schemas.microsoft.com/office/powerpoint/2010/main" val="810838374"/>
+        <p14:creationId xmlns:p14="http://schemas.microsoft.com/office/powerpoint/2010/main" val="103113034"/>
       </p:ext>
     </p:extLst>
   </p:cSld>

</xml_diff>

<commit_message>
Add FCFS presentation confidence interval sweeps
</commit_message>
<xml_diff>
--- a/presentation/FCFS Presentation.pptx
+++ b/presentation/FCFS Presentation.pptx
@@ -209,7 +209,7 @@
           <a:p>
             <a:fld id="{A3F00E0A-26B8-438F-8C49-C4126C0B2F07}" type="datetimeFigureOut">
               <a:rPr lang="en-CA" smtClean="0"/>
-              <a:t>2026-09-05</a:t>
+              <a:t>2026-09-07</a:t>
             </a:fld>
             <a:endParaRPr lang="en-CA"/>
           </a:p>
@@ -1199,7 +1199,7 @@
           <a:p>
             <a:fld id="{7559F276-CA16-4B7F-AC4C-2EDD18BC89A1}" type="datetimeFigureOut">
               <a:rPr lang="en-CA" smtClean="0"/>
-              <a:t>2026-09-05</a:t>
+              <a:t>2026-09-07</a:t>
             </a:fld>
             <a:endParaRPr lang="en-CA"/>
           </a:p>
@@ -1369,7 +1369,7 @@
           <a:p>
             <a:fld id="{7559F276-CA16-4B7F-AC4C-2EDD18BC89A1}" type="datetimeFigureOut">
               <a:rPr lang="en-CA" smtClean="0"/>
-              <a:t>2026-09-05</a:t>
+              <a:t>2026-09-07</a:t>
             </a:fld>
             <a:endParaRPr lang="en-CA"/>
           </a:p>
@@ -1549,7 +1549,7 @@
           <a:p>
             <a:fld id="{7559F276-CA16-4B7F-AC4C-2EDD18BC89A1}" type="datetimeFigureOut">
               <a:rPr lang="en-CA" smtClean="0"/>
-              <a:t>2026-09-05</a:t>
+              <a:t>2026-09-07</a:t>
             </a:fld>
             <a:endParaRPr lang="en-CA"/>
           </a:p>
@@ -1719,7 +1719,7 @@
           <a:p>
             <a:fld id="{7559F276-CA16-4B7F-AC4C-2EDD18BC89A1}" type="datetimeFigureOut">
               <a:rPr lang="en-CA" smtClean="0"/>
-              <a:t>2026-09-05</a:t>
+              <a:t>2026-09-07</a:t>
             </a:fld>
             <a:endParaRPr lang="en-CA"/>
           </a:p>
@@ -1965,7 +1965,7 @@
           <a:p>
             <a:fld id="{7559F276-CA16-4B7F-AC4C-2EDD18BC89A1}" type="datetimeFigureOut">
               <a:rPr lang="en-CA" smtClean="0"/>
-              <a:t>2026-09-05</a:t>
+              <a:t>2026-09-07</a:t>
             </a:fld>
             <a:endParaRPr lang="en-CA"/>
           </a:p>
@@ -2197,7 +2197,7 @@
           <a:p>
             <a:fld id="{7559F276-CA16-4B7F-AC4C-2EDD18BC89A1}" type="datetimeFigureOut">
               <a:rPr lang="en-CA" smtClean="0"/>
-              <a:t>2026-09-05</a:t>
+              <a:t>2026-09-07</a:t>
             </a:fld>
             <a:endParaRPr lang="en-CA"/>
           </a:p>
@@ -2564,7 +2564,7 @@
           <a:p>
             <a:fld id="{7559F276-CA16-4B7F-AC4C-2EDD18BC89A1}" type="datetimeFigureOut">
               <a:rPr lang="en-CA" smtClean="0"/>
-              <a:t>2026-09-05</a:t>
+              <a:t>2026-09-07</a:t>
             </a:fld>
             <a:endParaRPr lang="en-CA"/>
           </a:p>
@@ -2682,7 +2682,7 @@
           <a:p>
             <a:fld id="{7559F276-CA16-4B7F-AC4C-2EDD18BC89A1}" type="datetimeFigureOut">
               <a:rPr lang="en-CA" smtClean="0"/>
-              <a:t>2026-09-05</a:t>
+              <a:t>2026-09-07</a:t>
             </a:fld>
             <a:endParaRPr lang="en-CA"/>
           </a:p>
@@ -2777,7 +2777,7 @@
           <a:p>
             <a:fld id="{7559F276-CA16-4B7F-AC4C-2EDD18BC89A1}" type="datetimeFigureOut">
               <a:rPr lang="en-CA" smtClean="0"/>
-              <a:t>2026-09-05</a:t>
+              <a:t>2026-09-07</a:t>
             </a:fld>
             <a:endParaRPr lang="en-CA"/>
           </a:p>
@@ -3054,7 +3054,7 @@
           <a:p>
             <a:fld id="{7559F276-CA16-4B7F-AC4C-2EDD18BC89A1}" type="datetimeFigureOut">
               <a:rPr lang="en-CA" smtClean="0"/>
-              <a:t>2026-09-05</a:t>
+              <a:t>2026-09-07</a:t>
             </a:fld>
             <a:endParaRPr lang="en-CA"/>
           </a:p>
@@ -3311,7 +3311,7 @@
           <a:p>
             <a:fld id="{7559F276-CA16-4B7F-AC4C-2EDD18BC89A1}" type="datetimeFigureOut">
               <a:rPr lang="en-CA" smtClean="0"/>
-              <a:t>2026-09-05</a:t>
+              <a:t>2026-09-07</a:t>
             </a:fld>
             <a:endParaRPr lang="en-CA"/>
           </a:p>
@@ -3524,7 +3524,7 @@
           <a:p>
             <a:fld id="{7559F276-CA16-4B7F-AC4C-2EDD18BC89A1}" type="datetimeFigureOut">
               <a:rPr lang="en-CA" smtClean="0"/>
-              <a:t>2026-09-05</a:t>
+              <a:t>2026-09-07</a:t>
             </a:fld>
             <a:endParaRPr lang="en-CA"/>
           </a:p>

</xml_diff>